<commit_message>
docs: deliver architecture deck and verified thickness milestone
</commit_message>
<xml_diff>
--- a/docs/reports/2026-10-28-architecture/phymeo-newton-architecture.pptx
+++ b/docs/reports/2026-10-28-architecture/phymeo-newton-architecture.pptx
@@ -2,15 +2,15 @@
 <file path=ppt/presentation.xml><?xml version="1.0" encoding="utf-8"?>
 <p:presentation xmlns:p="http://schemas.openxmlformats.org/presentationml/2006/main">
   <p:sldMasterIdLst>
-    <p:sldMasterId xmlns:r="http://schemas.openxmlformats.org/officeDocument/2006/relationships" id="2147483648" r:id="Rd192daff339b49e1"/>
+    <p:sldMasterId xmlns:r="http://schemas.openxmlformats.org/officeDocument/2006/relationships" id="2147483648" r:id="R5804916c0cc14fba"/>
   </p:sldMasterIdLst>
   <p:notesMasterIdLst>
-    <p:notesMasterId xmlns:r="http://schemas.openxmlformats.org/officeDocument/2006/relationships" r:id="R9151dceb507d4421"/>
+    <p:notesMasterId xmlns:r="http://schemas.openxmlformats.org/officeDocument/2006/relationships" r:id="R7e492eb6322a45ac"/>
   </p:notesMasterIdLst>
   <p:sldIdLst>
-    <p:sldId xmlns:r="http://schemas.openxmlformats.org/officeDocument/2006/relationships" id="256" r:id="R298da63387764edd"/>
-    <p:sldId xmlns:r="http://schemas.openxmlformats.org/officeDocument/2006/relationships" id="257" r:id="Rff649ddca0e24534"/>
-    <p:sldId xmlns:r="http://schemas.openxmlformats.org/officeDocument/2006/relationships" id="258" r:id="R6543494eb2124bd5"/>
+    <p:sldId xmlns:r="http://schemas.openxmlformats.org/officeDocument/2006/relationships" id="256" r:id="R4bc2a4df89c94d3b"/>
+    <p:sldId xmlns:r="http://schemas.openxmlformats.org/officeDocument/2006/relationships" id="257" r:id="R98de7ec1681e4a7d"/>
+    <p:sldId xmlns:r="http://schemas.openxmlformats.org/officeDocument/2006/relationships" id="258" r:id="R3ade9165be4942a0"/>
   </p:sldIdLst>
   <p:sldSz cx="12192000" cy="6858000"/>
   <p:notesSz cx="6858000" cy="9144000"/>
@@ -544,7 +544,7 @@
           <a:lstStyle xmlns:a="http://schemas.openxmlformats.org/drawingml/2006/main"/>
           <a:p xmlns:a="http://schemas.openxmlformats.org/drawingml/2006/main">
             <a:r>
-              <a:t>Phymeo快照：codex/p6-5-handoff，提交73bcda611b5ed6dfe189aa78c28bc9cf31164abe。</a:t>
+              <a:t>Phymeo快照：codex/p6-5-handoff，提交10f8cdd72ee4c4d009386267f8adab35ed427255。</a:t>
             </a:r>
           </a:p>
           <a:p xmlns:a="http://schemas.openxmlformats.org/drawingml/2006/main">
@@ -629,7 +629,7 @@
           <a:lstStyle xmlns:a="http://schemas.openxmlformats.org/drawingml/2006/main"/>
           <a:p xmlns:a="http://schemas.openxmlformats.org/drawingml/2006/main">
             <a:r>
-              <a:t>当前代码与工程快照73bcda6；测试数字见docs/benchmarks/p65-control-engineering.json：CUDA1521，两个Python核心环境各1249；源码外wheel107文件一致；准确最终CI成功。</a:t>
+              <a:t>当前代码与工程快照10f8cdd；测试数字见docs/benchmarks/p65-offset-engineering.json：CUDA1559，两个Python核心环境各1284；源码外wheel108文件一致；远程CI在本次推送后独立核对。</a:t>
             </a:r>
           </a:p>
           <a:p xmlns:a="http://schemas.openxmlformats.org/drawingml/2006/main">
@@ -644,7 +644,7 @@
           </a:p>
           <a:p xmlns:a="http://schemas.openxmlformats.org/drawingml/2006/main">
             <a:r>
-              <a:t>P6.5六个已验收基础与缺口见docs/benchmarks/p65-window-delivery.md及docs/development/p65-continuation.md。Three.js可显示机器人变换、布网格和接触箭头，但不提供物理正确性。目标是离线真实仿真加同源回放，不是动画或实时求解器。</a:t>
+              <a:t>P6.5原六个基础加本次厚度端口共七项，范围见docs/benchmarks/p65-offset-acceptance.md与docs/development/p65-continuation.md。Three.js可显示机器人变换、布网格和接触箭头，但不提供物理正确性。目标是离线真实仿真加同源回放，不是动画或实时求解器。</a:t>
             </a:r>
           </a:p>
           <a:p xmlns:a="http://schemas.openxmlformats.org/drawingml/2006/main">
@@ -696,7 +696,7 @@
           <p:cNvPr id="3" name="Title">
             <a:extLst xmlns:a="http://schemas.openxmlformats.org/drawingml/2006/main">
               <a:ext uri="{FF2B5EF4-FFF2-40B4-BE49-F238E27FC236}">
-                <a16:creationId xmlns:a16="http://schemas.microsoft.com/office/drawing/2014/main" id="{FE823741-4971-4C50-A1A5-2C9B3E0CC4F1}"/>
+                <a16:creationId xmlns:a16="http://schemas.microsoft.com/office/drawing/2014/main" id="{BE4BC5C2-A890-4FB8-99A8-5E161CE87AA9}"/>
               </a:ext>
             </a:extLst>
           </p:cNvPr>
@@ -925,7 +925,7 @@
           <p:cNvPr id="2" name="Subtitle">
             <a:extLst xmlns:a="http://schemas.openxmlformats.org/drawingml/2006/main">
               <a:ext uri="{FF2B5EF4-FFF2-40B4-BE49-F238E27FC236}">
-                <a16:creationId xmlns:a16="http://schemas.microsoft.com/office/drawing/2014/main" id="{DF5BAD08-5D36-4EDB-8BEF-4F8476390BB2}"/>
+                <a16:creationId xmlns:a16="http://schemas.microsoft.com/office/drawing/2014/main" id="{AB8F02D4-3F4F-4BCB-8645-ADBCCF3E9CC1}"/>
               </a:ext>
             </a:extLst>
           </p:cNvPr>
@@ -1171,7 +1171,7 @@
           <p:cNvPr id="2" name="Section title">
             <a:extLst xmlns:a="http://schemas.openxmlformats.org/drawingml/2006/main">
               <a:ext uri="{FF2B5EF4-FFF2-40B4-BE49-F238E27FC236}">
-                <a16:creationId xmlns:a16="http://schemas.microsoft.com/office/drawing/2014/main" id="{28B7D250-DC45-47D2-BEDF-853259EA863E}"/>
+                <a16:creationId xmlns:a16="http://schemas.microsoft.com/office/drawing/2014/main" id="{08086CFC-45EC-42F9-94B1-0859AF1E983D}"/>
               </a:ext>
             </a:extLst>
           </p:cNvPr>
@@ -1417,7 +1417,7 @@
           <p:cNvPr id="3" name="Title">
             <a:extLst xmlns:a="http://schemas.openxmlformats.org/drawingml/2006/main">
               <a:ext uri="{FF2B5EF4-FFF2-40B4-BE49-F238E27FC236}">
-                <a16:creationId xmlns:a16="http://schemas.microsoft.com/office/drawing/2014/main" id="{F0636453-65EA-4931-B2F6-F8406051B1E5}"/>
+                <a16:creationId xmlns:a16="http://schemas.microsoft.com/office/drawing/2014/main" id="{88AE03F1-C215-4FDD-885B-449D87C143F0}"/>
               </a:ext>
             </a:extLst>
           </p:cNvPr>
@@ -1646,7 +1646,7 @@
           <p:cNvPr id="2" name="Body">
             <a:extLst xmlns:a="http://schemas.openxmlformats.org/drawingml/2006/main">
               <a:ext uri="{FF2B5EF4-FFF2-40B4-BE49-F238E27FC236}">
-                <a16:creationId xmlns:a16="http://schemas.microsoft.com/office/drawing/2014/main" id="{F0B04F5D-AE4F-4357-9C66-FF14503218B3}"/>
+                <a16:creationId xmlns:a16="http://schemas.microsoft.com/office/drawing/2014/main" id="{F2E45FA0-EEFA-4D66-A1BD-B275AF12FE3D}"/>
               </a:ext>
             </a:extLst>
           </p:cNvPr>
@@ -1892,7 +1892,7 @@
           <p:cNvPr id="4" name="Title">
             <a:extLst xmlns:a="http://schemas.openxmlformats.org/drawingml/2006/main">
               <a:ext uri="{FF2B5EF4-FFF2-40B4-BE49-F238E27FC236}">
-                <a16:creationId xmlns:a16="http://schemas.microsoft.com/office/drawing/2014/main" id="{1C37CC57-BCA4-46A5-BE83-849A12C174FC}"/>
+                <a16:creationId xmlns:a16="http://schemas.microsoft.com/office/drawing/2014/main" id="{E5A5D3F5-8D72-4FA7-A02C-DC74485081EC}"/>
               </a:ext>
             </a:extLst>
           </p:cNvPr>
@@ -2121,7 +2121,7 @@
           <p:cNvPr id="2" name="Left column">
             <a:extLst xmlns:a="http://schemas.openxmlformats.org/drawingml/2006/main">
               <a:ext uri="{FF2B5EF4-FFF2-40B4-BE49-F238E27FC236}">
-                <a16:creationId xmlns:a16="http://schemas.microsoft.com/office/drawing/2014/main" id="{B2874E09-3009-4213-A05F-F1A5B86275DD}"/>
+                <a16:creationId xmlns:a16="http://schemas.microsoft.com/office/drawing/2014/main" id="{C3B6346B-399F-43D8-BAE8-FB4850A10C6D}"/>
               </a:ext>
             </a:extLst>
           </p:cNvPr>
@@ -2350,7 +2350,7 @@
           <p:cNvPr id="3" name="Right column">
             <a:extLst xmlns:a="http://schemas.openxmlformats.org/drawingml/2006/main">
               <a:ext uri="{FF2B5EF4-FFF2-40B4-BE49-F238E27FC236}">
-                <a16:creationId xmlns:a16="http://schemas.microsoft.com/office/drawing/2014/main" id="{249C03E2-B7E7-4033-922E-82353B50185D}"/>
+                <a16:creationId xmlns:a16="http://schemas.microsoft.com/office/drawing/2014/main" id="{838E3AB1-6DD3-4A37-B040-EC77A51EFA81}"/>
               </a:ext>
             </a:extLst>
           </p:cNvPr>
@@ -2596,7 +2596,7 @@
           <p:cNvPr id="3" name="Title">
             <a:extLst xmlns:a="http://schemas.openxmlformats.org/drawingml/2006/main">
               <a:ext uri="{FF2B5EF4-FFF2-40B4-BE49-F238E27FC236}">
-                <a16:creationId xmlns:a16="http://schemas.microsoft.com/office/drawing/2014/main" id="{9A8B9C63-089C-4872-96D5-FFAEC5563689}"/>
+                <a16:creationId xmlns:a16="http://schemas.microsoft.com/office/drawing/2014/main" id="{88F8BC06-4698-4425-976A-AC6A8C9442D1}"/>
               </a:ext>
             </a:extLst>
           </p:cNvPr>
@@ -2825,7 +2825,7 @@
           <p:cNvPr id="2" name="Left column">
             <a:extLst xmlns:a="http://schemas.openxmlformats.org/drawingml/2006/main">
               <a:ext uri="{FF2B5EF4-FFF2-40B4-BE49-F238E27FC236}">
-                <a16:creationId xmlns:a16="http://schemas.microsoft.com/office/drawing/2014/main" id="{FABACE90-205E-4FD0-9860-E695006E1C70}"/>
+                <a16:creationId xmlns:a16="http://schemas.microsoft.com/office/drawing/2014/main" id="{90120123-C564-40E7-82F1-3B8A58E497B3}"/>
               </a:ext>
             </a:extLst>
           </p:cNvPr>
@@ -3092,12 +3092,12 @@
   </p:cSld>
   <p:clrMap bg1="lt1" tx1="dk1" bg2="lt2" tx2="dk2" accent1="accent1" accent2="accent2" accent3="accent3" accent4="accent4" accent5="accent5" accent6="accent6" hlink="hlink" folHlink="folHlink"/>
   <p:sldLayoutIdLst>
-    <p:sldLayoutId xmlns:r="http://schemas.openxmlformats.org/officeDocument/2006/relationships" id="2147483649" r:id="R034f2edf44dd47c8"/>
-    <p:sldLayoutId xmlns:r="http://schemas.openxmlformats.org/officeDocument/2006/relationships" id="2147483650" r:id="Re5035156d54f4510"/>
-    <p:sldLayoutId xmlns:r="http://schemas.openxmlformats.org/officeDocument/2006/relationships" id="2147483651" r:id="R6b351d29cbfa47a8"/>
-    <p:sldLayoutId xmlns:r="http://schemas.openxmlformats.org/officeDocument/2006/relationships" id="2147483652" r:id="R48765fd3890d448f"/>
-    <p:sldLayoutId xmlns:r="http://schemas.openxmlformats.org/officeDocument/2006/relationships" id="2147483653" r:id="Ra4dca10cae7e48a0"/>
-    <p:sldLayoutId xmlns:r="http://schemas.openxmlformats.org/officeDocument/2006/relationships" id="2147483654" r:id="Rce52ad522f484ede"/>
+    <p:sldLayoutId xmlns:r="http://schemas.openxmlformats.org/officeDocument/2006/relationships" id="2147483649" r:id="R8a9d1517ea3142f3"/>
+    <p:sldLayoutId xmlns:r="http://schemas.openxmlformats.org/officeDocument/2006/relationships" id="2147483650" r:id="R76409f6a8061426c"/>
+    <p:sldLayoutId xmlns:r="http://schemas.openxmlformats.org/officeDocument/2006/relationships" id="2147483651" r:id="R7c6426035dca4690"/>
+    <p:sldLayoutId xmlns:r="http://schemas.openxmlformats.org/officeDocument/2006/relationships" id="2147483652" r:id="Rb556544654d84a22"/>
+    <p:sldLayoutId xmlns:r="http://schemas.openxmlformats.org/officeDocument/2006/relationships" id="2147483653" r:id="R7bdd6f962fe44693"/>
+    <p:sldLayoutId xmlns:r="http://schemas.openxmlformats.org/officeDocument/2006/relationships" id="2147483654" r:id="Ra56d4c0231c4457b"/>
   </p:sldLayoutIdLst>
   <p:txStyles>
     <p:titleStyle>
@@ -3648,7 +3648,7 @@
           <p:cNvPr id="30" name="">
             <a:extLst xmlns:a="http://schemas.openxmlformats.org/drawingml/2006/main">
               <a:ext uri="{FF2B5EF4-FFF2-40B4-BE49-F238E27FC236}">
-                <a16:creationId xmlns:a16="http://schemas.microsoft.com/office/drawing/2014/main" id="{9FF5259E-8A28-4EFD-81AF-C3686CE1DC41}"/>
+                <a16:creationId xmlns:a16="http://schemas.microsoft.com/office/drawing/2014/main" id="{A416FD8E-0148-4CE7-8DCD-516486C2AC21}"/>
               </a:ext>
             </a:extLst>
           </p:cNvPr>
@@ -3805,7 +3805,7 @@
           <p:cNvPr id="2" name="">
             <a:extLst xmlns:a="http://schemas.openxmlformats.org/drawingml/2006/main">
               <a:ext uri="{FF2B5EF4-FFF2-40B4-BE49-F238E27FC236}">
-                <a16:creationId xmlns:a16="http://schemas.microsoft.com/office/drawing/2014/main" id="{0BF50020-A324-4179-863F-3459E928E6C3}"/>
+                <a16:creationId xmlns:a16="http://schemas.microsoft.com/office/drawing/2014/main" id="{CE61F1EA-7FD9-431B-9541-DFA8B9E0C1F4}"/>
               </a:ext>
             </a:extLst>
           </p:cNvPr>
@@ -3962,7 +3962,7 @@
           <p:cNvPr id="3" name="">
             <a:extLst xmlns:a="http://schemas.openxmlformats.org/drawingml/2006/main">
               <a:ext uri="{FF2B5EF4-FFF2-40B4-BE49-F238E27FC236}">
-                <a16:creationId xmlns:a16="http://schemas.microsoft.com/office/drawing/2014/main" id="{D529F4DF-AAAF-4772-8D7B-F2BE2D535A11}"/>
+                <a16:creationId xmlns:a16="http://schemas.microsoft.com/office/drawing/2014/main" id="{4C7958FA-2DF2-4C8F-B89B-B2366FB39D4B}"/>
               </a:ext>
             </a:extLst>
           </p:cNvPr>
@@ -3993,7 +3993,7 @@
           <p:cNvPr id="4" name="">
             <a:extLst xmlns:a="http://schemas.openxmlformats.org/drawingml/2006/main">
               <a:ext uri="{FF2B5EF4-FFF2-40B4-BE49-F238E27FC236}">
-                <a16:creationId xmlns:a16="http://schemas.microsoft.com/office/drawing/2014/main" id="{A9FDF09F-BC2C-41DA-8647-7903B193F925}"/>
+                <a16:creationId xmlns:a16="http://schemas.microsoft.com/office/drawing/2014/main" id="{FCB53ED1-1F7B-47BD-9FC4-18AEDFE4BF46}"/>
               </a:ext>
             </a:extLst>
           </p:cNvPr>
@@ -4173,7 +4173,7 @@
           <p:cNvPr id="5" name="">
             <a:extLst xmlns:a="http://schemas.openxmlformats.org/drawingml/2006/main">
               <a:ext uri="{FF2B5EF4-FFF2-40B4-BE49-F238E27FC236}">
-                <a16:creationId xmlns:a16="http://schemas.microsoft.com/office/drawing/2014/main" id="{8535B7AF-7C2A-48AC-8EA5-10F18E3108FC}"/>
+                <a16:creationId xmlns:a16="http://schemas.microsoft.com/office/drawing/2014/main" id="{B4D4AA48-0971-46EE-901C-803D73DFFD6E}"/>
               </a:ext>
             </a:extLst>
           </p:cNvPr>
@@ -4204,7 +4204,7 @@
           <p:cNvPr id="6" name="">
             <a:extLst xmlns:a="http://schemas.openxmlformats.org/drawingml/2006/main">
               <a:ext uri="{FF2B5EF4-FFF2-40B4-BE49-F238E27FC236}">
-                <a16:creationId xmlns:a16="http://schemas.microsoft.com/office/drawing/2014/main" id="{6BC3E2FD-7065-46ED-A715-C9D1E784DE84}"/>
+                <a16:creationId xmlns:a16="http://schemas.microsoft.com/office/drawing/2014/main" id="{056CCD1A-8561-4FE3-A896-21AD7318D720}"/>
               </a:ext>
             </a:extLst>
           </p:cNvPr>
@@ -4235,7 +4235,7 @@
           <p:cNvPr id="7" name="">
             <a:extLst xmlns:a="http://schemas.openxmlformats.org/drawingml/2006/main">
               <a:ext uri="{FF2B5EF4-FFF2-40B4-BE49-F238E27FC236}">
-                <a16:creationId xmlns:a16="http://schemas.microsoft.com/office/drawing/2014/main" id="{E1B311EC-F1C9-4D9E-A8D1-77906BB93314}"/>
+                <a16:creationId xmlns:a16="http://schemas.microsoft.com/office/drawing/2014/main" id="{1A206BAB-718B-4046-81B2-4E4C4C5CCCF6}"/>
               </a:ext>
             </a:extLst>
           </p:cNvPr>
@@ -4392,7 +4392,7 @@
           <p:cNvPr id="8" name="">
             <a:extLst xmlns:a="http://schemas.openxmlformats.org/drawingml/2006/main">
               <a:ext uri="{FF2B5EF4-FFF2-40B4-BE49-F238E27FC236}">
-                <a16:creationId xmlns:a16="http://schemas.microsoft.com/office/drawing/2014/main" id="{9746954C-354B-4820-8A6E-50639ECAD81B}"/>
+                <a16:creationId xmlns:a16="http://schemas.microsoft.com/office/drawing/2014/main" id="{62609DB0-76A1-434B-AD0C-17B7FE2BB798}"/>
               </a:ext>
             </a:extLst>
           </p:cNvPr>
@@ -4423,7 +4423,7 @@
           <p:cNvPr id="9" name="">
             <a:extLst xmlns:a="http://schemas.openxmlformats.org/drawingml/2006/main">
               <a:ext uri="{FF2B5EF4-FFF2-40B4-BE49-F238E27FC236}">
-                <a16:creationId xmlns:a16="http://schemas.microsoft.com/office/drawing/2014/main" id="{1E60078E-3978-4214-945C-1C86230B130D}"/>
+                <a16:creationId xmlns:a16="http://schemas.microsoft.com/office/drawing/2014/main" id="{C4C07A19-160D-40CD-BD55-6B5A46605B7E}"/>
               </a:ext>
             </a:extLst>
           </p:cNvPr>
@@ -4454,7 +4454,7 @@
           <p:cNvPr id="10" name="">
             <a:extLst xmlns:a="http://schemas.openxmlformats.org/drawingml/2006/main">
               <a:ext uri="{FF2B5EF4-FFF2-40B4-BE49-F238E27FC236}">
-                <a16:creationId xmlns:a16="http://schemas.microsoft.com/office/drawing/2014/main" id="{DC2E0649-9466-4055-A925-A2441DC9B8E7}"/>
+                <a16:creationId xmlns:a16="http://schemas.microsoft.com/office/drawing/2014/main" id="{6052F2E5-4677-4778-A648-476AFDDB421B}"/>
               </a:ext>
             </a:extLst>
           </p:cNvPr>
@@ -4634,7 +4634,7 @@
           <p:cNvPr id="11" name="">
             <a:extLst xmlns:a="http://schemas.openxmlformats.org/drawingml/2006/main">
               <a:ext uri="{FF2B5EF4-FFF2-40B4-BE49-F238E27FC236}">
-                <a16:creationId xmlns:a16="http://schemas.microsoft.com/office/drawing/2014/main" id="{BE7E5B32-41E4-419A-84E7-7FBBB0F544AA}"/>
+                <a16:creationId xmlns:a16="http://schemas.microsoft.com/office/drawing/2014/main" id="{C81E01FB-DCF6-4F20-BFD9-117EE81BB5E5}"/>
               </a:ext>
             </a:extLst>
           </p:cNvPr>
@@ -4665,7 +4665,7 @@
           <p:cNvPr id="12" name="">
             <a:extLst xmlns:a="http://schemas.openxmlformats.org/drawingml/2006/main">
               <a:ext uri="{FF2B5EF4-FFF2-40B4-BE49-F238E27FC236}">
-                <a16:creationId xmlns:a16="http://schemas.microsoft.com/office/drawing/2014/main" id="{30DD4CBC-97D5-4E23-9752-1D562CB1BA79}"/>
+                <a16:creationId xmlns:a16="http://schemas.microsoft.com/office/drawing/2014/main" id="{0A99C925-1596-447B-81E1-E8ED139A9E40}"/>
               </a:ext>
             </a:extLst>
           </p:cNvPr>
@@ -4822,7 +4822,7 @@
           <p:cNvPr id="13" name="">
             <a:extLst xmlns:a="http://schemas.openxmlformats.org/drawingml/2006/main">
               <a:ext uri="{FF2B5EF4-FFF2-40B4-BE49-F238E27FC236}">
-                <a16:creationId xmlns:a16="http://schemas.microsoft.com/office/drawing/2014/main" id="{5571D732-AA5D-445A-B869-6DF97E4543E3}"/>
+                <a16:creationId xmlns:a16="http://schemas.microsoft.com/office/drawing/2014/main" id="{9A0A6704-CDAC-41F4-9ED0-07186423F0DC}"/>
               </a:ext>
             </a:extLst>
           </p:cNvPr>
@@ -4853,7 +4853,7 @@
           <p:cNvPr id="14" name="">
             <a:extLst xmlns:a="http://schemas.openxmlformats.org/drawingml/2006/main">
               <a:ext uri="{FF2B5EF4-FFF2-40B4-BE49-F238E27FC236}">
-                <a16:creationId xmlns:a16="http://schemas.microsoft.com/office/drawing/2014/main" id="{39676E4A-1F58-4A97-8970-1EB2B3D35BF7}"/>
+                <a16:creationId xmlns:a16="http://schemas.microsoft.com/office/drawing/2014/main" id="{D251710C-01BF-4313-89A1-19005CB96F47}"/>
               </a:ext>
             </a:extLst>
           </p:cNvPr>
@@ -5033,7 +5033,7 @@
           <p:cNvPr id="15" name="">
             <a:extLst xmlns:a="http://schemas.openxmlformats.org/drawingml/2006/main">
               <a:ext uri="{FF2B5EF4-FFF2-40B4-BE49-F238E27FC236}">
-                <a16:creationId xmlns:a16="http://schemas.microsoft.com/office/drawing/2014/main" id="{5A891472-9D78-490C-9BF6-0AAFD6ED028B}"/>
+                <a16:creationId xmlns:a16="http://schemas.microsoft.com/office/drawing/2014/main" id="{B2D0437B-67E6-4097-9867-77608A4F1A86}"/>
               </a:ext>
             </a:extLst>
           </p:cNvPr>
@@ -5064,7 +5064,7 @@
           <p:cNvPr id="16" name="">
             <a:extLst xmlns:a="http://schemas.openxmlformats.org/drawingml/2006/main">
               <a:ext uri="{FF2B5EF4-FFF2-40B4-BE49-F238E27FC236}">
-                <a16:creationId xmlns:a16="http://schemas.microsoft.com/office/drawing/2014/main" id="{47EFC9F8-CC72-4EC2-9469-5D91AE8D8B99}"/>
+                <a16:creationId xmlns:a16="http://schemas.microsoft.com/office/drawing/2014/main" id="{DDC5D934-2A95-4537-B2A1-3E145340B41B}"/>
               </a:ext>
             </a:extLst>
           </p:cNvPr>
@@ -5244,7 +5244,7 @@
           <p:cNvPr id="17" name="">
             <a:extLst xmlns:a="http://schemas.openxmlformats.org/drawingml/2006/main">
               <a:ext uri="{FF2B5EF4-FFF2-40B4-BE49-F238E27FC236}">
-                <a16:creationId xmlns:a16="http://schemas.microsoft.com/office/drawing/2014/main" id="{D0784276-5E3E-4F86-AA77-D6243D32FE65}"/>
+                <a16:creationId xmlns:a16="http://schemas.microsoft.com/office/drawing/2014/main" id="{7717CA93-3798-4F95-BA7F-196053B28DF9}"/>
               </a:ext>
             </a:extLst>
           </p:cNvPr>
@@ -5275,7 +5275,7 @@
           <p:cNvPr id="18" name="">
             <a:extLst xmlns:a="http://schemas.openxmlformats.org/drawingml/2006/main">
               <a:ext uri="{FF2B5EF4-FFF2-40B4-BE49-F238E27FC236}">
-                <a16:creationId xmlns:a16="http://schemas.microsoft.com/office/drawing/2014/main" id="{E4912CE8-EAC4-40CC-9187-93E6DE666BAA}"/>
+                <a16:creationId xmlns:a16="http://schemas.microsoft.com/office/drawing/2014/main" id="{BDE7463F-81AE-4BD7-98FC-B6BEC2897C6C}"/>
               </a:ext>
             </a:extLst>
           </p:cNvPr>
@@ -5306,7 +5306,7 @@
           <p:cNvPr id="19" name="">
             <a:extLst xmlns:a="http://schemas.openxmlformats.org/drawingml/2006/main">
               <a:ext uri="{FF2B5EF4-FFF2-40B4-BE49-F238E27FC236}">
-                <a16:creationId xmlns:a16="http://schemas.microsoft.com/office/drawing/2014/main" id="{E2CD674F-6F7A-40B3-8181-F9E4905177E8}"/>
+                <a16:creationId xmlns:a16="http://schemas.microsoft.com/office/drawing/2014/main" id="{A1028229-535A-4C0C-A994-1FA92B8ABC1A}"/>
               </a:ext>
             </a:extLst>
           </p:cNvPr>
@@ -5337,7 +5337,7 @@
           <p:cNvPr id="20" name="">
             <a:extLst xmlns:a="http://schemas.openxmlformats.org/drawingml/2006/main">
               <a:ext uri="{FF2B5EF4-FFF2-40B4-BE49-F238E27FC236}">
-                <a16:creationId xmlns:a16="http://schemas.microsoft.com/office/drawing/2014/main" id="{863BF677-5A44-4E90-9E4D-0E3CD1D91765}"/>
+                <a16:creationId xmlns:a16="http://schemas.microsoft.com/office/drawing/2014/main" id="{4AAEE2E7-4687-4020-BE0A-2A8E18265CBE}"/>
               </a:ext>
             </a:extLst>
           </p:cNvPr>
@@ -5494,7 +5494,7 @@
           <p:cNvPr id="21" name="">
             <a:extLst xmlns:a="http://schemas.openxmlformats.org/drawingml/2006/main">
               <a:ext uri="{FF2B5EF4-FFF2-40B4-BE49-F238E27FC236}">
-                <a16:creationId xmlns:a16="http://schemas.microsoft.com/office/drawing/2014/main" id="{13EA5A03-E440-469A-85F8-84A76C8A7257}"/>
+                <a16:creationId xmlns:a16="http://schemas.microsoft.com/office/drawing/2014/main" id="{C408BFDE-B89D-43D2-8E5D-1A5C13235050}"/>
               </a:ext>
             </a:extLst>
           </p:cNvPr>
@@ -5651,7 +5651,7 @@
           <p:cNvPr id="22" name="">
             <a:extLst xmlns:a="http://schemas.openxmlformats.org/drawingml/2006/main">
               <a:ext uri="{FF2B5EF4-FFF2-40B4-BE49-F238E27FC236}">
-                <a16:creationId xmlns:a16="http://schemas.microsoft.com/office/drawing/2014/main" id="{C102F56D-0677-4FB3-9333-A8EA961A9A74}"/>
+                <a16:creationId xmlns:a16="http://schemas.microsoft.com/office/drawing/2014/main" id="{B330320E-E104-4B6B-BA2B-6CC674441903}"/>
               </a:ext>
             </a:extLst>
           </p:cNvPr>
@@ -5682,7 +5682,7 @@
           <p:cNvPr id="23" name="">
             <a:extLst xmlns:a="http://schemas.openxmlformats.org/drawingml/2006/main">
               <a:ext uri="{FF2B5EF4-FFF2-40B4-BE49-F238E27FC236}">
-                <a16:creationId xmlns:a16="http://schemas.microsoft.com/office/drawing/2014/main" id="{01C74FAA-E459-4B4C-85D5-D48888579F73}"/>
+                <a16:creationId xmlns:a16="http://schemas.microsoft.com/office/drawing/2014/main" id="{C042DBBB-3E32-4359-8FFF-4AE254EDD463}"/>
               </a:ext>
             </a:extLst>
           </p:cNvPr>
@@ -5839,7 +5839,7 @@
           <p:cNvPr id="24" name="">
             <a:extLst xmlns:a="http://schemas.openxmlformats.org/drawingml/2006/main">
               <a:ext uri="{FF2B5EF4-FFF2-40B4-BE49-F238E27FC236}">
-                <a16:creationId xmlns:a16="http://schemas.microsoft.com/office/drawing/2014/main" id="{DD691FC8-24E6-41D8-A658-5F4A3254D0CA}"/>
+                <a16:creationId xmlns:a16="http://schemas.microsoft.com/office/drawing/2014/main" id="{13E73E8C-2AEB-47A7-B15C-F27120045F6D}"/>
               </a:ext>
             </a:extLst>
           </p:cNvPr>
@@ -5996,7 +5996,7 @@
           <p:cNvPr id="25" name="">
             <a:extLst xmlns:a="http://schemas.openxmlformats.org/drawingml/2006/main">
               <a:ext uri="{FF2B5EF4-FFF2-40B4-BE49-F238E27FC236}">
-                <a16:creationId xmlns:a16="http://schemas.microsoft.com/office/drawing/2014/main" id="{87B9FE41-0BEF-4ECA-B756-F97227898F9F}"/>
+                <a16:creationId xmlns:a16="http://schemas.microsoft.com/office/drawing/2014/main" id="{2349CF72-0F9E-46C7-8B18-1DA92DF8337C}"/>
               </a:ext>
             </a:extLst>
           </p:cNvPr>
@@ -6153,7 +6153,7 @@
           <p:cNvPr id="26" name="">
             <a:extLst xmlns:a="http://schemas.openxmlformats.org/drawingml/2006/main">
               <a:ext uri="{FF2B5EF4-FFF2-40B4-BE49-F238E27FC236}">
-                <a16:creationId xmlns:a16="http://schemas.microsoft.com/office/drawing/2014/main" id="{36821A5C-C432-4425-8BBA-94D479CD7253}"/>
+                <a16:creationId xmlns:a16="http://schemas.microsoft.com/office/drawing/2014/main" id="{AEE085D3-460A-4B10-9E40-757127F217F2}"/>
               </a:ext>
             </a:extLst>
           </p:cNvPr>
@@ -6310,7 +6310,7 @@
           <p:cNvPr id="27" name="">
             <a:extLst xmlns:a="http://schemas.openxmlformats.org/drawingml/2006/main">
               <a:ext uri="{FF2B5EF4-FFF2-40B4-BE49-F238E27FC236}">
-                <a16:creationId xmlns:a16="http://schemas.microsoft.com/office/drawing/2014/main" id="{A3DE095B-EC58-4D0B-9E00-3A17276BAC7B}"/>
+                <a16:creationId xmlns:a16="http://schemas.microsoft.com/office/drawing/2014/main" id="{B4FF4142-5BDD-42D5-9CA1-2B4B310684E9}"/>
               </a:ext>
             </a:extLst>
           </p:cNvPr>
@@ -6513,7 +6513,7 @@
           <p:cNvPr id="28" name="">
             <a:extLst xmlns:a="http://schemas.openxmlformats.org/drawingml/2006/main">
               <a:ext uri="{FF2B5EF4-FFF2-40B4-BE49-F238E27FC236}">
-                <a16:creationId xmlns:a16="http://schemas.microsoft.com/office/drawing/2014/main" id="{29637D3F-57AC-45E2-B424-6728365D27E1}"/>
+                <a16:creationId xmlns:a16="http://schemas.microsoft.com/office/drawing/2014/main" id="{8FE2CF8C-B20D-4329-8EB3-136FC8E49E38}"/>
               </a:ext>
             </a:extLst>
           </p:cNvPr>
@@ -6670,7 +6670,7 @@
           <p:cNvPr id="29" name="">
             <a:extLst xmlns:a="http://schemas.openxmlformats.org/drawingml/2006/main">
               <a:ext uri="{FF2B5EF4-FFF2-40B4-BE49-F238E27FC236}">
-                <a16:creationId xmlns:a16="http://schemas.microsoft.com/office/drawing/2014/main" id="{1A4C14C1-539A-4491-970F-998005966C07}"/>
+                <a16:creationId xmlns:a16="http://schemas.microsoft.com/office/drawing/2014/main" id="{3D373128-273E-40F7-AA89-97FAAEB5A2A2}"/>
               </a:ext>
             </a:extLst>
           </p:cNvPr>
@@ -6825,7 +6825,7 @@
     </p:spTree>
     <p:extLst>
       <p:ext uri="{BB962C8B-B14F-4D97-AF65-F5344CB8AC3E}">
-        <p14:creationId xmlns:p14="http://schemas.microsoft.com/office/powerpoint/2010/main" val="2036222627"/>
+        <p14:creationId xmlns:p14="http://schemas.microsoft.com/office/powerpoint/2010/main" val="1637510456"/>
       </p:ext>
     </p:extLst>
   </p:cSld>
@@ -6856,7 +6856,7 @@
           <p:cNvPr id="20" name="">
             <a:extLst xmlns:a="http://schemas.openxmlformats.org/drawingml/2006/main">
               <a:ext uri="{FF2B5EF4-FFF2-40B4-BE49-F238E27FC236}">
-                <a16:creationId xmlns:a16="http://schemas.microsoft.com/office/drawing/2014/main" id="{C42AA572-181D-4933-929F-332F07C2D8CF}"/>
+                <a16:creationId xmlns:a16="http://schemas.microsoft.com/office/drawing/2014/main" id="{94CFE2A6-A3AB-412B-AAF2-31B990806AE6}"/>
               </a:ext>
             </a:extLst>
           </p:cNvPr>
@@ -7013,7 +7013,7 @@
           <p:cNvPr id="2" name="">
             <a:extLst xmlns:a="http://schemas.openxmlformats.org/drawingml/2006/main">
               <a:ext uri="{FF2B5EF4-FFF2-40B4-BE49-F238E27FC236}">
-                <a16:creationId xmlns:a16="http://schemas.microsoft.com/office/drawing/2014/main" id="{3D4D7340-4920-473E-A44C-C4DB94D21AFD}"/>
+                <a16:creationId xmlns:a16="http://schemas.microsoft.com/office/drawing/2014/main" id="{95BD034F-3ACB-41EE-B762-17D9B06852A0}"/>
               </a:ext>
             </a:extLst>
           </p:cNvPr>
@@ -7170,7 +7170,7 @@
           <p:cNvPr id="3" name="">
             <a:extLst xmlns:a="http://schemas.openxmlformats.org/drawingml/2006/main">
               <a:ext uri="{FF2B5EF4-FFF2-40B4-BE49-F238E27FC236}">
-                <a16:creationId xmlns:a16="http://schemas.microsoft.com/office/drawing/2014/main" id="{26ED2908-61F3-475E-BDF0-2DB46DD1794B}"/>
+                <a16:creationId xmlns:a16="http://schemas.microsoft.com/office/drawing/2014/main" id="{5FEB44AC-1EBC-453E-B345-DAD10933754D}"/>
               </a:ext>
             </a:extLst>
           </p:cNvPr>
@@ -7201,7 +7201,7 @@
           <p:cNvPr id="4" name="">
             <a:extLst xmlns:a="http://schemas.openxmlformats.org/drawingml/2006/main">
               <a:ext uri="{FF2B5EF4-FFF2-40B4-BE49-F238E27FC236}">
-                <a16:creationId xmlns:a16="http://schemas.microsoft.com/office/drawing/2014/main" id="{C316ADF6-B343-4689-8DF0-0C673CB612D8}"/>
+                <a16:creationId xmlns:a16="http://schemas.microsoft.com/office/drawing/2014/main" id="{ED8B0417-951D-4CEF-AF54-2F89EEEC72A1}"/>
               </a:ext>
             </a:extLst>
           </p:cNvPr>
@@ -7358,7 +7358,7 @@
           <p:cNvPr id="5" name="">
             <a:extLst xmlns:a="http://schemas.openxmlformats.org/drawingml/2006/main">
               <a:ext uri="{FF2B5EF4-FFF2-40B4-BE49-F238E27FC236}">
-                <a16:creationId xmlns:a16="http://schemas.microsoft.com/office/drawing/2014/main" id="{B6EDAFFE-5480-48A4-8708-B75D385DA4EB}"/>
+                <a16:creationId xmlns:a16="http://schemas.microsoft.com/office/drawing/2014/main" id="{2B977994-C516-441F-83FE-729738707340}"/>
               </a:ext>
             </a:extLst>
           </p:cNvPr>
@@ -7389,7 +7389,7 @@
           <p:cNvPr id="6" name="">
             <a:extLst xmlns:a="http://schemas.openxmlformats.org/drawingml/2006/main">
               <a:ext uri="{FF2B5EF4-FFF2-40B4-BE49-F238E27FC236}">
-                <a16:creationId xmlns:a16="http://schemas.microsoft.com/office/drawing/2014/main" id="{F8C66184-3FED-41EF-9489-9E57B3E1B722}"/>
+                <a16:creationId xmlns:a16="http://schemas.microsoft.com/office/drawing/2014/main" id="{9E4501C1-EF94-410D-A5B1-73D8526624BD}"/>
               </a:ext>
             </a:extLst>
           </p:cNvPr>
@@ -7420,7 +7420,7 @@
           <p:cNvPr id="7" name="">
             <a:extLst xmlns:a="http://schemas.openxmlformats.org/drawingml/2006/main">
               <a:ext uri="{FF2B5EF4-FFF2-40B4-BE49-F238E27FC236}">
-                <a16:creationId xmlns:a16="http://schemas.microsoft.com/office/drawing/2014/main" id="{B22D8AD8-E02E-4425-A5C7-722998C14CFD}"/>
+                <a16:creationId xmlns:a16="http://schemas.microsoft.com/office/drawing/2014/main" id="{B337C211-2044-419A-B3E5-F7D31BE31599}"/>
               </a:ext>
             </a:extLst>
           </p:cNvPr>
@@ -7600,7 +7600,7 @@
           <p:cNvPr id="8" name="">
             <a:extLst xmlns:a="http://schemas.openxmlformats.org/drawingml/2006/main">
               <a:ext uri="{FF2B5EF4-FFF2-40B4-BE49-F238E27FC236}">
-                <a16:creationId xmlns:a16="http://schemas.microsoft.com/office/drawing/2014/main" id="{AEA5C574-4A4F-4347-B600-963E314597C2}"/>
+                <a16:creationId xmlns:a16="http://schemas.microsoft.com/office/drawing/2014/main" id="{B7C500B1-5AFB-4852-AA04-72ADECC8DBD6}"/>
               </a:ext>
             </a:extLst>
           </p:cNvPr>
@@ -7631,7 +7631,7 @@
           <p:cNvPr id="9" name="">
             <a:extLst xmlns:a="http://schemas.openxmlformats.org/drawingml/2006/main">
               <a:ext uri="{FF2B5EF4-FFF2-40B4-BE49-F238E27FC236}">
-                <a16:creationId xmlns:a16="http://schemas.microsoft.com/office/drawing/2014/main" id="{82BE677B-EF86-47A1-9A09-5C0A9B866D42}"/>
+                <a16:creationId xmlns:a16="http://schemas.microsoft.com/office/drawing/2014/main" id="{0784648D-FAC0-4BE9-B5B8-E97CC940608B}"/>
               </a:ext>
             </a:extLst>
           </p:cNvPr>
@@ -7662,7 +7662,7 @@
           <p:cNvPr id="10" name="">
             <a:extLst xmlns:a="http://schemas.openxmlformats.org/drawingml/2006/main">
               <a:ext uri="{FF2B5EF4-FFF2-40B4-BE49-F238E27FC236}">
-                <a16:creationId xmlns:a16="http://schemas.microsoft.com/office/drawing/2014/main" id="{59D6660C-64E8-4609-B364-F67EBA65FB33}"/>
+                <a16:creationId xmlns:a16="http://schemas.microsoft.com/office/drawing/2014/main" id="{A62BCB43-855E-4A96-8A44-3798D228E5A4}"/>
               </a:ext>
             </a:extLst>
           </p:cNvPr>
@@ -7842,7 +7842,7 @@
           <p:cNvPr id="11" name="">
             <a:extLst xmlns:a="http://schemas.openxmlformats.org/drawingml/2006/main">
               <a:ext uri="{FF2B5EF4-FFF2-40B4-BE49-F238E27FC236}">
-                <a16:creationId xmlns:a16="http://schemas.microsoft.com/office/drawing/2014/main" id="{EBC4EA93-B8C6-4EBD-B79B-A4C04071DBC5}"/>
+                <a16:creationId xmlns:a16="http://schemas.microsoft.com/office/drawing/2014/main" id="{0D917BC5-B001-463C-8051-7FDBA57F99C9}"/>
               </a:ext>
             </a:extLst>
           </p:cNvPr>
@@ -7873,7 +7873,7 @@
           <p:cNvPr id="12" name="">
             <a:extLst xmlns:a="http://schemas.openxmlformats.org/drawingml/2006/main">
               <a:ext uri="{FF2B5EF4-FFF2-40B4-BE49-F238E27FC236}">
-                <a16:creationId xmlns:a16="http://schemas.microsoft.com/office/drawing/2014/main" id="{35A6AE01-240A-4238-BA98-332FC0763501}"/>
+                <a16:creationId xmlns:a16="http://schemas.microsoft.com/office/drawing/2014/main" id="{C571B6C3-A688-4ABF-84C9-5B3B705361D4}"/>
               </a:ext>
             </a:extLst>
           </p:cNvPr>
@@ -7904,7 +7904,7 @@
           <p:cNvPr id="13" name="">
             <a:extLst xmlns:a="http://schemas.openxmlformats.org/drawingml/2006/main">
               <a:ext uri="{FF2B5EF4-FFF2-40B4-BE49-F238E27FC236}">
-                <a16:creationId xmlns:a16="http://schemas.microsoft.com/office/drawing/2014/main" id="{47C824B7-7535-42A0-ACD4-7AF7557FFC04}"/>
+                <a16:creationId xmlns:a16="http://schemas.microsoft.com/office/drawing/2014/main" id="{10257B1E-F624-4994-B94E-33F9892F97F9}"/>
               </a:ext>
             </a:extLst>
           </p:cNvPr>
@@ -8061,7 +8061,7 @@
           <p:cNvPr id="14" name="">
             <a:extLst xmlns:a="http://schemas.openxmlformats.org/drawingml/2006/main">
               <a:ext uri="{FF2B5EF4-FFF2-40B4-BE49-F238E27FC236}">
-                <a16:creationId xmlns:a16="http://schemas.microsoft.com/office/drawing/2014/main" id="{89940544-3D7B-4048-AE1A-383964F89E90}"/>
+                <a16:creationId xmlns:a16="http://schemas.microsoft.com/office/drawing/2014/main" id="{C76D9216-FF7F-4492-BF4A-C7EC91B90833}"/>
               </a:ext>
             </a:extLst>
           </p:cNvPr>
@@ -8218,7 +8218,7 @@
           <p:cNvPr id="15" name="">
             <a:extLst xmlns:a="http://schemas.openxmlformats.org/drawingml/2006/main">
               <a:ext uri="{FF2B5EF4-FFF2-40B4-BE49-F238E27FC236}">
-                <a16:creationId xmlns:a16="http://schemas.microsoft.com/office/drawing/2014/main" id="{82FA4289-C29E-4CBB-839F-768EC474D0DA}"/>
+                <a16:creationId xmlns:a16="http://schemas.microsoft.com/office/drawing/2014/main" id="{D0E855BF-9205-4054-A995-4584FA63D413}"/>
               </a:ext>
             </a:extLst>
           </p:cNvPr>
@@ -8910,7 +8910,7 @@
           <p:cNvPr id="16" name="">
             <a:extLst xmlns:a="http://schemas.openxmlformats.org/drawingml/2006/main">
               <a:ext uri="{FF2B5EF4-FFF2-40B4-BE49-F238E27FC236}">
-                <a16:creationId xmlns:a16="http://schemas.microsoft.com/office/drawing/2014/main" id="{C0D9C743-A73E-4CB2-9A9A-8FDE5743F51F}"/>
+                <a16:creationId xmlns:a16="http://schemas.microsoft.com/office/drawing/2014/main" id="{70929BBD-FE1F-44E6-ADBD-912BE7C54EAD}"/>
               </a:ext>
             </a:extLst>
           </p:cNvPr>
@@ -9067,7 +9067,7 @@
           <p:cNvPr id="17" name="">
             <a:extLst xmlns:a="http://schemas.openxmlformats.org/drawingml/2006/main">
               <a:ext uri="{FF2B5EF4-FFF2-40B4-BE49-F238E27FC236}">
-                <a16:creationId xmlns:a16="http://schemas.microsoft.com/office/drawing/2014/main" id="{8097286C-DD2F-46EF-A6D8-34A0FB9E724B}"/>
+                <a16:creationId xmlns:a16="http://schemas.microsoft.com/office/drawing/2014/main" id="{6BE5D68C-49CD-4E59-9121-5C02923384A2}"/>
               </a:ext>
             </a:extLst>
           </p:cNvPr>
@@ -9224,7 +9224,7 @@
           <p:cNvPr id="18" name="">
             <a:extLst xmlns:a="http://schemas.openxmlformats.org/drawingml/2006/main">
               <a:ext uri="{FF2B5EF4-FFF2-40B4-BE49-F238E27FC236}">
-                <a16:creationId xmlns:a16="http://schemas.microsoft.com/office/drawing/2014/main" id="{A80F08C6-59A7-4A8F-A06F-65F8C8B9CABC}"/>
+                <a16:creationId xmlns:a16="http://schemas.microsoft.com/office/drawing/2014/main" id="{57A83519-3B66-4D59-AEB8-07EFA52C502C}"/>
               </a:ext>
             </a:extLst>
           </p:cNvPr>
@@ -9371,7 +9371,7 @@
                 <a:ea typeface="Microsoft YaHei"/>
                 <a:cs typeface="Microsoft YaHei"/>
               </a:rPr>
-              <a:t>PHY MEO  ·  73bcda6  ·  2026.10.28</a:t>
+              <a:t>PHY MEO  ·  10f8cdd  ·  2026.10.28</a:t>
             </a:r>
           </a:p>
         </p:txBody>
@@ -9381,7 +9381,7 @@
           <p:cNvPr id="19" name="">
             <a:extLst xmlns:a="http://schemas.openxmlformats.org/drawingml/2006/main">
               <a:ext uri="{FF2B5EF4-FFF2-40B4-BE49-F238E27FC236}">
-                <a16:creationId xmlns:a16="http://schemas.microsoft.com/office/drawing/2014/main" id="{66A6D037-56CA-417F-AE67-F7CBD3A2327A}"/>
+                <a16:creationId xmlns:a16="http://schemas.microsoft.com/office/drawing/2014/main" id="{B7CC129D-CD08-44CC-8D8E-05B721C7E9DD}"/>
               </a:ext>
             </a:extLst>
           </p:cNvPr>
@@ -9536,7 +9536,7 @@
     </p:spTree>
     <p:extLst>
       <p:ext uri="{BB962C8B-B14F-4D97-AF65-F5344CB8AC3E}">
-        <p14:creationId xmlns:p14="http://schemas.microsoft.com/office/powerpoint/2010/main" val="1403170627"/>
+        <p14:creationId xmlns:p14="http://schemas.microsoft.com/office/powerpoint/2010/main" val="875401746"/>
       </p:ext>
     </p:extLst>
   </p:cSld>
@@ -9567,7 +9567,7 @@
           <p:cNvPr id="13" name="">
             <a:extLst xmlns:a="http://schemas.openxmlformats.org/drawingml/2006/main">
               <a:ext uri="{FF2B5EF4-FFF2-40B4-BE49-F238E27FC236}">
-                <a16:creationId xmlns:a16="http://schemas.microsoft.com/office/drawing/2014/main" id="{E21F4938-8411-45B2-B833-0EB0BC969EE2}"/>
+                <a16:creationId xmlns:a16="http://schemas.microsoft.com/office/drawing/2014/main" id="{B343A7D7-81C9-4839-AE7E-36D87F4B8914}"/>
               </a:ext>
             </a:extLst>
           </p:cNvPr>
@@ -9724,7 +9724,7 @@
           <p:cNvPr id="2" name="">
             <a:extLst xmlns:a="http://schemas.openxmlformats.org/drawingml/2006/main">
               <a:ext uri="{FF2B5EF4-FFF2-40B4-BE49-F238E27FC236}">
-                <a16:creationId xmlns:a16="http://schemas.microsoft.com/office/drawing/2014/main" id="{8C309148-8E73-4599-AB0A-74C3EEF5A241}"/>
+                <a16:creationId xmlns:a16="http://schemas.microsoft.com/office/drawing/2014/main" id="{AF88AFDC-8DBE-4D86-902D-3E8F3484837C}"/>
               </a:ext>
             </a:extLst>
           </p:cNvPr>
@@ -9881,7 +9881,7 @@
           <p:cNvPr id="3" name="">
             <a:extLst xmlns:a="http://schemas.openxmlformats.org/drawingml/2006/main">
               <a:ext uri="{FF2B5EF4-FFF2-40B4-BE49-F238E27FC236}">
-                <a16:creationId xmlns:a16="http://schemas.microsoft.com/office/drawing/2014/main" id="{5B93FE6E-AF11-4451-B8B8-0DC51334F4AA}"/>
+                <a16:creationId xmlns:a16="http://schemas.microsoft.com/office/drawing/2014/main" id="{CEA40B3A-BF83-456A-9780-D89DEB0FA852}"/>
               </a:ext>
             </a:extLst>
           </p:cNvPr>
@@ -9891,7 +9891,7 @@
           <p:nvPr/>
         </p:nvPicPr>
         <p:blipFill>
-          <a:blip xmlns:r="http://schemas.openxmlformats.org/officeDocument/2006/relationships" xmlns:a="http://schemas.openxmlformats.org/drawingml/2006/main" r:embed="R621d1a74fbad4d8c"/>
+          <a:blip xmlns:r="http://schemas.openxmlformats.org/officeDocument/2006/relationships" xmlns:a="http://schemas.openxmlformats.org/drawingml/2006/main" r:embed="R9d31d915a8664770"/>
           <a:srcRect xmlns:a="http://schemas.openxmlformats.org/drawingml/2006/main" l="21661" t="34679" r="24188" b="29216"/>
           <a:stretch xmlns:a="http://schemas.openxmlformats.org/drawingml/2006/main"/>
         </p:blipFill>
@@ -9910,7 +9910,7 @@
           <p:cNvPr id="4" name="">
             <a:extLst xmlns:a="http://schemas.openxmlformats.org/drawingml/2006/main">
               <a:ext uri="{FF2B5EF4-FFF2-40B4-BE49-F238E27FC236}">
-                <a16:creationId xmlns:a16="http://schemas.microsoft.com/office/drawing/2014/main" id="{96D1B152-AC9F-4008-9386-07EB633584BA}"/>
+                <a16:creationId xmlns:a16="http://schemas.microsoft.com/office/drawing/2014/main" id="{FE4CDE35-8DAF-425A-A137-0A824515D25F}"/>
               </a:ext>
             </a:extLst>
           </p:cNvPr>
@@ -10090,7 +10090,7 @@
           <p:cNvPr id="5" name="">
             <a:extLst xmlns:a="http://schemas.openxmlformats.org/drawingml/2006/main">
               <a:ext uri="{FF2B5EF4-FFF2-40B4-BE49-F238E27FC236}">
-                <a16:creationId xmlns:a16="http://schemas.microsoft.com/office/drawing/2014/main" id="{B1E3E695-944C-4315-9A2D-A578B39A6D1F}"/>
+                <a16:creationId xmlns:a16="http://schemas.microsoft.com/office/drawing/2014/main" id="{8B32A2E2-8B6B-4190-B3EC-633E1E6C6914}"/>
               </a:ext>
             </a:extLst>
           </p:cNvPr>
@@ -10247,7 +10247,7 @@
           <p:cNvPr id="6" name="">
             <a:extLst xmlns:a="http://schemas.openxmlformats.org/drawingml/2006/main">
               <a:ext uri="{FF2B5EF4-FFF2-40B4-BE49-F238E27FC236}">
-                <a16:creationId xmlns:a16="http://schemas.microsoft.com/office/drawing/2014/main" id="{94608BDE-0E28-4A6D-BAFB-E49C79F32C86}"/>
+                <a16:creationId xmlns:a16="http://schemas.microsoft.com/office/drawing/2014/main" id="{3D5AF124-E390-4B54-9498-2D5964EA0B95}"/>
               </a:ext>
             </a:extLst>
           </p:cNvPr>
@@ -10394,7 +10394,7 @@
                 <a:ea typeface="Microsoft YaHei"/>
                 <a:cs typeface="Microsoft YaHei"/>
               </a:rPr>
-              <a:t>1521</a:t>
+              <a:t>1559</a:t>
             </a:r>
           </a:p>
         </p:txBody>
@@ -10404,7 +10404,7 @@
           <p:cNvPr id="7" name="">
             <a:extLst xmlns:a="http://schemas.openxmlformats.org/drawingml/2006/main">
               <a:ext uri="{FF2B5EF4-FFF2-40B4-BE49-F238E27FC236}">
-                <a16:creationId xmlns:a16="http://schemas.microsoft.com/office/drawing/2014/main" id="{21750BCD-1E7A-4835-87B8-834FC2ACA1A5}"/>
+                <a16:creationId xmlns:a16="http://schemas.microsoft.com/office/drawing/2014/main" id="{FA85C8D1-AE21-4B4E-9CE3-F69D91ED1B68}"/>
               </a:ext>
             </a:extLst>
           </p:cNvPr>
@@ -10551,7 +10551,7 @@
                 <a:ea typeface="Microsoft YaHei"/>
                 <a:cs typeface="Microsoft YaHei"/>
               </a:rPr>
-              <a:t>CUDA 测试套件通过 · 代码快照 73bcda6</a:t>
+              <a:t>CUDA 测试套件通过 · 代码快照 10f8cdd</a:t>
             </a:r>
           </a:p>
         </p:txBody>
@@ -10561,7 +10561,7 @@
           <p:cNvPr id="8" name="">
             <a:extLst xmlns:a="http://schemas.openxmlformats.org/drawingml/2006/main">
               <a:ext uri="{FF2B5EF4-FFF2-40B4-BE49-F238E27FC236}">
-                <a16:creationId xmlns:a16="http://schemas.microsoft.com/office/drawing/2014/main" id="{C8194BCE-E4EB-4DDE-8A77-98380854EDFA}"/>
+                <a16:creationId xmlns:a16="http://schemas.microsoft.com/office/drawing/2014/main" id="{373DFCBF-248D-403A-99AD-C1D4AEB85D78}"/>
               </a:ext>
             </a:extLst>
           </p:cNvPr>
@@ -10708,7 +10708,7 @@
                 <a:ea typeface="Microsoft YaHei"/>
                 <a:cs typeface="Microsoft YaHei"/>
               </a:rPr>
-              <a:t>6 个基础模块已完成</a:t>
+              <a:t>7 个基础模块已完成</a:t>
             </a:r>
           </a:p>
         </p:txBody>
@@ -10718,7 +10718,7 @@
           <p:cNvPr id="9" name="">
             <a:extLst xmlns:a="http://schemas.openxmlformats.org/drawingml/2006/main">
               <a:ext uri="{FF2B5EF4-FFF2-40B4-BE49-F238E27FC236}">
-                <a16:creationId xmlns:a16="http://schemas.microsoft.com/office/drawing/2014/main" id="{1EBD1EF3-9A95-41DC-8039-965F547BD999}"/>
+                <a16:creationId xmlns:a16="http://schemas.microsoft.com/office/drawing/2014/main" id="{78482DD3-5E96-4112-9150-AF2983952113}"/>
               </a:ext>
             </a:extLst>
           </p:cNvPr>
@@ -10729,8 +10729,8 @@
         </p:nvSpPr>
         <p:spPr>
           <a:xfrm xmlns:a="http://schemas.openxmlformats.org/drawingml/2006/main">
-            <a:off x="6819900" y="3476625"/>
-            <a:ext cx="4686300" cy="657225"/>
+            <a:off x="6819900" y="3438525"/>
+            <a:ext cx="4686300" cy="885825"/>
           </a:xfrm>
           <a:prstGeom xmlns:a="http://schemas.openxmlformats.org/drawingml/2006/main" prst="rect">
             <a:avLst/>
@@ -10745,7 +10745,7 @@
           <a:bodyPr xmlns:a="http://schemas.openxmlformats.org/drawingml/2006/main" lIns="0" tIns="0" rIns="0" bIns="0"/>
           <a:lstStyle xmlns:a="http://schemas.openxmlformats.org/drawingml/2006/main">
             <a:defPPr algn="l">
-              <a:defRPr sz="1575" b="0">
+              <a:defRPr sz="1500" b="0">
                 <a:solidFill>
                   <a:srgbClr val="CDE1DD"/>
                 </a:solidFill>
@@ -10755,7 +10755,7 @@
               </a:defRPr>
             </a:defPPr>
             <a:lvl1pPr algn="l">
-              <a:defRPr sz="1575" b="0">
+              <a:defRPr sz="1500" b="0">
                 <a:solidFill>
                   <a:srgbClr val="CDE1DD"/>
                 </a:solidFill>
@@ -10765,7 +10765,7 @@
               </a:defRPr>
             </a:lvl1pPr>
             <a:lvl2pPr algn="l">
-              <a:defRPr sz="1575" b="0">
+              <a:defRPr sz="1500" b="0">
                 <a:solidFill>
                   <a:srgbClr val="CDE1DD"/>
                 </a:solidFill>
@@ -10775,7 +10775,7 @@
               </a:defRPr>
             </a:lvl2pPr>
             <a:lvl3pPr algn="l">
-              <a:defRPr sz="1575" b="0">
+              <a:defRPr sz="1500" b="0">
                 <a:solidFill>
                   <a:srgbClr val="CDE1DD"/>
                 </a:solidFill>
@@ -10785,7 +10785,7 @@
               </a:defRPr>
             </a:lvl3pPr>
             <a:lvl4pPr algn="l">
-              <a:defRPr sz="1575" b="0">
+              <a:defRPr sz="1500" b="0">
                 <a:solidFill>
                   <a:srgbClr val="CDE1DD"/>
                 </a:solidFill>
@@ -10795,7 +10795,7 @@
               </a:defRPr>
             </a:lvl4pPr>
             <a:lvl5pPr algn="l">
-              <a:defRPr sz="1575" b="0">
+              <a:defRPr sz="1500" b="0">
                 <a:solidFill>
                   <a:srgbClr val="CDE1DD"/>
                 </a:solidFill>
@@ -10805,7 +10805,7 @@
               </a:defRPr>
             </a:lvl5pPr>
             <a:lvl6pPr algn="l">
-              <a:defRPr sz="1575" b="0">
+              <a:defRPr sz="1500" b="0">
                 <a:solidFill>
                   <a:srgbClr val="CDE1DD"/>
                 </a:solidFill>
@@ -10815,7 +10815,7 @@
               </a:defRPr>
             </a:lvl6pPr>
             <a:lvl7pPr algn="l">
-              <a:defRPr sz="1575" b="0">
+              <a:defRPr sz="1500" b="0">
                 <a:solidFill>
                   <a:srgbClr val="CDE1DD"/>
                 </a:solidFill>
@@ -10825,7 +10825,7 @@
               </a:defRPr>
             </a:lvl7pPr>
             <a:lvl8pPr algn="l">
-              <a:defRPr sz="1575" b="0">
+              <a:defRPr sz="1500" b="0">
                 <a:solidFill>
                   <a:srgbClr val="CDE1DD"/>
                 </a:solidFill>
@@ -10835,7 +10835,7 @@
               </a:defRPr>
             </a:lvl8pPr>
             <a:lvl9pPr algn="l">
-              <a:defRPr sz="1575" b="0">
+              <a:defRPr sz="1500" b="0">
                 <a:solidFill>
                   <a:srgbClr val="CDE1DD"/>
                 </a:solidFill>
@@ -10847,7 +10847,7 @@
           </a:lstStyle>
           <a:p xmlns:a="http://schemas.openxmlformats.org/drawingml/2006/main">
             <a:pPr algn="l">
-              <a:defRPr sz="1575" b="0">
+              <a:defRPr sz="1500" b="0">
                 <a:solidFill>
                   <a:srgbClr val="CDE1DD"/>
                 </a:solidFill>
@@ -10857,7 +10857,7 @@
               </a:defRPr>
             </a:pPr>
             <a:r>
-              <a:rPr sz="1575" b="0">
+              <a:rPr sz="1500" b="0">
                 <a:solidFill>
                   <a:srgbClr val="CDE1DD"/>
                 </a:solidFill>
@@ -10870,7 +10870,7 @@
           </a:p>
           <a:p xmlns:a="http://schemas.openxmlformats.org/drawingml/2006/main">
             <a:pPr algn="l">
-              <a:defRPr sz="1575" b="0">
+              <a:defRPr sz="1500" b="0">
                 <a:solidFill>
                   <a:srgbClr val="CDE1DD"/>
                 </a:solidFill>
@@ -10880,7 +10880,7 @@
               </a:defRPr>
             </a:pPr>
             <a:r>
-              <a:rPr sz="1575" b="0">
+              <a:rPr sz="1500" b="0">
                 <a:solidFill>
                   <a:srgbClr val="CDE1DD"/>
                 </a:solidFill>
@@ -10888,7 +10888,30 @@
                 <a:ea typeface="Microsoft YaHei"/>
                 <a:cs typeface="Microsoft YaHei"/>
               </a:rPr>
-              <a:t>局部摩擦 · 瞬时接触 · 有限驱动核心</a:t>
+              <a:t>局部摩擦 · 瞬时接触 · 有限驱动</a:t>
+            </a:r>
+          </a:p>
+          <a:p xmlns:a="http://schemas.openxmlformats.org/drawingml/2006/main">
+            <a:pPr algn="l">
+              <a:defRPr sz="1500" b="0">
+                <a:solidFill>
+                  <a:srgbClr val="CDE1DD"/>
+                </a:solidFill>
+                <a:latin typeface="Microsoft YaHei"/>
+                <a:ea typeface="Microsoft YaHei"/>
+                <a:cs typeface="Microsoft YaHei"/>
+              </a:defRPr>
+            </a:pPr>
+            <a:r>
+              <a:rPr sz="1500" b="0">
+                <a:solidFill>
+                  <a:srgbClr val="CDE1DD"/>
+                </a:solidFill>
+                <a:latin typeface="Microsoft YaHei"/>
+                <a:ea typeface="Microsoft YaHei"/>
+                <a:cs typeface="Microsoft YaHei"/>
+              </a:rPr>
+              <a:t>新增：布厚度速度与反力矩</a:t>
             </a:r>
           </a:p>
         </p:txBody>
@@ -10898,7 +10921,7 @@
           <p:cNvPr id="10" name="">
             <a:extLst xmlns:a="http://schemas.openxmlformats.org/drawingml/2006/main">
               <a:ext uri="{FF2B5EF4-FFF2-40B4-BE49-F238E27FC236}">
-                <a16:creationId xmlns:a16="http://schemas.microsoft.com/office/drawing/2014/main" id="{703E51D1-E07E-433B-9717-0818A86CEE1D}"/>
+                <a16:creationId xmlns:a16="http://schemas.microsoft.com/office/drawing/2014/main" id="{A29A79CB-CA91-483E-A3F2-C09610EFB97B}"/>
               </a:ext>
             </a:extLst>
           </p:cNvPr>
@@ -11055,7 +11078,7 @@
           <p:cNvPr id="11" name="">
             <a:extLst xmlns:a="http://schemas.openxmlformats.org/drawingml/2006/main">
               <a:ext uri="{FF2B5EF4-FFF2-40B4-BE49-F238E27FC236}">
-                <a16:creationId xmlns:a16="http://schemas.microsoft.com/office/drawing/2014/main" id="{AA5B675A-E307-4CD8-B0FF-E05160A4F9F0}"/>
+                <a16:creationId xmlns:a16="http://schemas.microsoft.com/office/drawing/2014/main" id="{F6FE89C3-4EB6-43A2-908B-4E0F1376347A}"/>
               </a:ext>
             </a:extLst>
           </p:cNvPr>
@@ -11235,7 +11258,7 @@
           <p:cNvPr id="12" name="">
             <a:extLst xmlns:a="http://schemas.openxmlformats.org/drawingml/2006/main">
               <a:ext uri="{FF2B5EF4-FFF2-40B4-BE49-F238E27FC236}">
-                <a16:creationId xmlns:a16="http://schemas.microsoft.com/office/drawing/2014/main" id="{48FCC50B-9CF9-4FE3-882F-2EDFEF2C0FF4}"/>
+                <a16:creationId xmlns:a16="http://schemas.microsoft.com/office/drawing/2014/main" id="{4768FC88-0F58-4E00-9E8F-2F26CF0E7B37}"/>
               </a:ext>
             </a:extLst>
           </p:cNvPr>
@@ -11390,7 +11413,7 @@
     </p:spTree>
     <p:extLst>
       <p:ext uri="{BB962C8B-B14F-4D97-AF65-F5344CB8AC3E}">
-        <p14:creationId xmlns:p14="http://schemas.microsoft.com/office/powerpoint/2010/main" val="1966425534"/>
+        <p14:creationId xmlns:p14="http://schemas.microsoft.com/office/powerpoint/2010/main" val="2124018261"/>
       </p:ext>
     </p:extLst>
   </p:cSld>

</xml_diff>